<commit_message>
Submission deck: fix em-dash escape, add real demo video and product links
</commit_message>
<xml_diff>
--- a/docs/FundTrace-submission.pptx
+++ b/docs/FundTrace-submission.pptx
@@ -8351,7 +8351,7 @@
                 </a:solidFill>
                 <a:latin typeface="Google Sans Flex"/>
               </a:rPr>
-              <a:t>  [add after recording — see docs/record_demo.py]</a:t>
+              <a:t>  https://www.youtube.com/watch?v=KNB5TJZJ1Qw</a:t>
             </a:r>
             <a:endParaRPr>
               <a:latin typeface="Google Sans Flex Medium"/>
@@ -8388,7 +8388,7 @@
                 </a:solidFill>
                 <a:latin typeface="Google Sans Flex"/>
               </a:rPr>
-              <a:t>  https://fundtrace-541805214490.asia-south1.run.app</a:t>
+              <a:t>  https://fundtrace-541805214490.asia-south1.run.app/login</a:t>
             </a:r>
             <a:endParaRPr>
               <a:latin typeface="Google Sans Flex Medium"/>

</xml_diff>